<commit_message>
Update PDF and PPTX slide decks to 10-slide comprehensive challenge layout
</commit_message>
<xml_diff>
--- a/guardian_ai_presentation.pptx
+++ b/guardian_ai_presentation.pptx
@@ -11,6 +11,10 @@
     <p:sldId id="259" r:id="rId10"/>
     <p:sldId id="260" r:id="rId11"/>
     <p:sldId id="261" r:id="rId12"/>
+    <p:sldId id="262" r:id="rId13"/>
+    <p:sldId id="263" r:id="rId14"/>
+    <p:sldId id="264" r:id="rId15"/>
+    <p:sldId id="265" r:id="rId16"/>
   </p:sldIdLst>
   <p:sldSz cx="12191695" cy="6858000" type="screen4x3"/>
   <p:notesSz cx="6858000" cy="9144000"/>
@@ -3166,7 +3170,6 @@
           </a:bodyPr>
           <a:lstStyle/>
           <a:p>
-            <a:pPr algn="l"/>
             <a:r>
               <a:rPr sz="5600" b="1">
                 <a:solidFill>
@@ -3178,7 +3181,7 @@
             </a:r>
           </a:p>
           <a:p>
-            <a:pPr algn="l">
+            <a:pPr>
               <a:spcBef>
                 <a:spcPts val="1200"/>
               </a:spcBef>
@@ -3235,6 +3238,208 @@
                 <a:latin typeface="Arial"/>
               </a:rPr>
               <a:t>Developer &amp; Architect: Jatin Rajpoot</a:t>
+            </a:r>
+          </a:p>
+        </p:txBody>
+      </p:sp>
+    </p:spTree>
+  </p:cSld>
+  <p:clrMapOvr>
+    <a:masterClrMapping/>
+  </p:clrMapOvr>
+</p:sld>
+</file>
+
+<file path=ppt/slides/slide10.xml><?xml version="1.0" encoding="utf-8"?>
+<p:sld xmlns:a="http://schemas.openxmlformats.org/drawingml/2006/main" xmlns:p="http://schemas.openxmlformats.org/presentationml/2006/main" xmlns:r="http://schemas.openxmlformats.org/officeDocument/2006/relationships">
+  <p:cSld>
+    <p:bg>
+      <p:bgPr>
+        <a:solidFill>
+          <a:srgbClr val="FFFFFF"/>
+        </a:solidFill>
+        <a:effectLst/>
+      </p:bgPr>
+    </p:bg>
+    <p:spTree>
+      <p:nvGrpSpPr>
+        <p:cNvPr id="1" name=""/>
+        <p:cNvGrpSpPr/>
+        <p:nvPr/>
+      </p:nvGrpSpPr>
+      <p:grpSpPr/>
+      <p:sp>
+        <p:nvSpPr>
+          <p:cNvPr id="2" name="Rectangle 1"/>
+          <p:cNvSpPr/>
+          <p:nvPr/>
+        </p:nvSpPr>
+        <p:spPr>
+          <a:xfrm>
+            <a:off x="0" y="0"/>
+            <a:ext cx="12191695" cy="1005840"/>
+          </a:xfrm>
+          <a:prstGeom prst="rect">
+            <a:avLst/>
+          </a:prstGeom>
+          <a:solidFill>
+            <a:srgbClr val="0F172A"/>
+          </a:solidFill>
+          <a:ln>
+            <a:noFill/>
+          </a:ln>
+        </p:spPr>
+        <p:style>
+          <a:lnRef idx="1">
+            <a:schemeClr val="accent1"/>
+          </a:lnRef>
+          <a:fillRef idx="3">
+            <a:schemeClr val="accent1"/>
+          </a:fillRef>
+          <a:effectRef idx="2">
+            <a:schemeClr val="accent1"/>
+          </a:effectRef>
+          <a:fontRef idx="minor">
+            <a:schemeClr val="lt1"/>
+          </a:fontRef>
+        </p:style>
+        <p:txBody>
+          <a:bodyPr rtlCol="0" anchor="ctr"/>
+          <a:lstStyle/>
+          <a:p>
+            <a:pPr algn="ctr"/>
+          </a:p>
+        </p:txBody>
+      </p:sp>
+      <p:sp>
+        <p:nvSpPr>
+          <p:cNvPr id="3" name="TextBox 2"/>
+          <p:cNvSpPr txBox="1"/>
+          <p:nvPr/>
+        </p:nvSpPr>
+        <p:spPr>
+          <a:xfrm>
+            <a:off x="548640" y="182880"/>
+            <a:ext cx="11094415" cy="640080"/>
+          </a:xfrm>
+          <a:prstGeom prst="rect">
+            <a:avLst/>
+          </a:prstGeom>
+          <a:noFill/>
+        </p:spPr>
+        <p:txBody>
+          <a:bodyPr wrap="square">
+            <a:spAutoFit/>
+          </a:bodyPr>
+          <a:lstStyle/>
+          <a:p>
+            <a:r>
+              <a:rPr sz="2800" b="1">
+                <a:solidFill>
+                  <a:srgbClr val="FFFFFF"/>
+                </a:solidFill>
+                <a:latin typeface="Arial"/>
+              </a:rPr>
+              <a:t>Summary &amp; Future Vision</a:t>
+            </a:r>
+          </a:p>
+        </p:txBody>
+      </p:sp>
+      <p:sp>
+        <p:nvSpPr>
+          <p:cNvPr id="4" name="TextBox 3"/>
+          <p:cNvSpPr txBox="1"/>
+          <p:nvPr/>
+        </p:nvSpPr>
+        <p:spPr>
+          <a:xfrm>
+            <a:off x="731520" y="1463040"/>
+            <a:ext cx="10698480" cy="4572000"/>
+          </a:xfrm>
+          <a:prstGeom prst="rect">
+            <a:avLst/>
+          </a:prstGeom>
+          <a:noFill/>
+        </p:spPr>
+        <p:txBody>
+          <a:bodyPr wrap="square">
+            <a:spAutoFit/>
+          </a:bodyPr>
+          <a:lstStyle/>
+          <a:p/>
+          <a:p>
+            <a:pPr>
+              <a:spcBef>
+                <a:spcPts val="1000"/>
+              </a:spcBef>
+            </a:pPr>
+            <a:r>
+              <a:rPr sz="1500" b="1">
+                <a:solidFill>
+                  <a:srgbClr val="0E7490"/>
+                </a:solidFill>
+                <a:latin typeface="Arial"/>
+              </a:rPr>
+              <a:t>•  Mass Adoption: </a:t>
+            </a:r>
+            <a:r>
+              <a:rPr sz="1400">
+                <a:solidFill>
+                  <a:srgbClr val="334155"/>
+                </a:solidFill>
+                <a:latin typeface="Arial"/>
+              </a:rPr>
+              <a:t>Low CPU footprint allows it to run on entry-level dashboards and standard smartphones.</a:t>
+            </a:r>
+          </a:p>
+          <a:p>
+            <a:pPr>
+              <a:spcBef>
+                <a:spcPts val="1000"/>
+              </a:spcBef>
+            </a:pPr>
+            <a:r>
+              <a:rPr sz="1500" b="1">
+                <a:solidFill>
+                  <a:srgbClr val="0E7490"/>
+                </a:solidFill>
+                <a:latin typeface="Arial"/>
+              </a:rPr>
+              <a:t>•  Cloud Deployments: </a:t>
+            </a:r>
+            <a:r>
+              <a:rPr sz="1400">
+                <a:solidFill>
+                  <a:srgbClr val="334155"/>
+                </a:solidFill>
+                <a:latin typeface="Arial"/>
+              </a:rPr>
+              <a:t>Fully configured for Vercel deployment with dynamic WebSocket proxying.</a:t>
+            </a:r>
+          </a:p>
+          <a:p>
+            <a:pPr>
+              <a:spcBef>
+                <a:spcPts val="1000"/>
+              </a:spcBef>
+            </a:pPr>
+            <a:r>
+              <a:rPr sz="1500" b="1">
+                <a:solidFill>
+                  <a:srgbClr val="0E7490"/>
+                </a:solidFill>
+                <a:latin typeface="Arial"/>
+              </a:rPr>
+              <a:t>•  Future V2X Integration: </a:t>
+            </a:r>
+            <a:r>
+              <a:rPr sz="1400">
+                <a:solidFill>
+                  <a:srgbClr val="334155"/>
+                </a:solidFill>
+                <a:latin typeface="Arial"/>
+              </a:rPr>
+              <a:t>Connects to surrounding cars over 5G to negotiate lane changes during emergency brake maneuvers.</a:t>
             </a:r>
           </a:p>
         </p:txBody>
@@ -3330,7 +3535,6 @@
           </a:bodyPr>
           <a:lstStyle/>
           <a:p>
-            <a:pPr algn="l"/>
             <a:r>
               <a:rPr sz="2800" b="1">
                 <a:solidFill>
@@ -3468,7 +3672,7 @@
                 </a:solidFill>
                 <a:latin typeface="Arial"/>
               </a:rPr>
-              <a:t>Traditional cameras lack edge computer vision to compute real-time risks and alert drivers actively.</a:t>
+              <a:t>Traditional dashcams lack edge computer vision to compute real-time risks and alert drivers actively.</a:t>
             </a:r>
           </a:p>
         </p:txBody>
@@ -3564,7 +3768,6 @@
           </a:bodyPr>
           <a:lstStyle/>
           <a:p>
-            <a:pPr algn="l"/>
             <a:r>
               <a:rPr sz="2800" b="1">
                 <a:solidFill>
@@ -3572,66 +3775,21 @@
                 </a:solidFill>
                 <a:latin typeface="Arial"/>
               </a:rPr>
-              <a:t>What We Built: Closed-Loop AI Safety System</a:t>
-            </a:r>
-          </a:p>
-        </p:txBody>
-      </p:sp>
-      <p:sp>
-        <p:nvSpPr>
-          <p:cNvPr id="4" name="Rectangle 3"/>
-          <p:cNvSpPr/>
-          <p:nvPr/>
-        </p:nvSpPr>
-        <p:spPr>
-          <a:xfrm>
-            <a:off x="548640" y="1645920"/>
-            <a:ext cx="2651760" cy="4297680"/>
-          </a:xfrm>
-          <a:prstGeom prst="rect">
-            <a:avLst/>
-          </a:prstGeom>
-          <a:solidFill>
-            <a:srgbClr val="F1F5F9"/>
-          </a:solidFill>
-          <a:ln w="19050">
-            <a:solidFill>
-              <a:srgbClr val="E2E8F0"/>
-            </a:solidFill>
-          </a:ln>
-        </p:spPr>
-        <p:style>
-          <a:lnRef idx="1">
-            <a:schemeClr val="accent1"/>
-          </a:lnRef>
-          <a:fillRef idx="3">
-            <a:schemeClr val="accent1"/>
-          </a:fillRef>
-          <a:effectRef idx="2">
-            <a:schemeClr val="accent1"/>
-          </a:effectRef>
-          <a:fontRef idx="minor">
-            <a:schemeClr val="lt1"/>
-          </a:fontRef>
-        </p:style>
-        <p:txBody>
-          <a:bodyPr rtlCol="0" anchor="ctr"/>
-          <a:lstStyle/>
-          <a:p>
-            <a:pPr algn="ctr"/>
-          </a:p>
-        </p:txBody>
-      </p:sp>
-      <p:sp>
-        <p:nvSpPr>
-          <p:cNvPr id="5" name="TextBox 4"/>
+              <a:t>Executive Summary: The GuardianAI Vision</a:t>
+            </a:r>
+          </a:p>
+        </p:txBody>
+      </p:sp>
+      <p:sp>
+        <p:nvSpPr>
+          <p:cNvPr id="4" name="TextBox 3"/>
           <p:cNvSpPr txBox="1"/>
           <p:nvPr/>
         </p:nvSpPr>
         <p:spPr>
           <a:xfrm>
-            <a:off x="685800" y="1828800"/>
-            <a:ext cx="2377440" cy="3931920"/>
+            <a:off x="731520" y="1463040"/>
+            <a:ext cx="10698480" cy="4572000"/>
           </a:xfrm>
           <a:prstGeom prst="rect">
             <a:avLst/>
@@ -3646,333 +3804,108 @@
           <a:p>
             <a:pPr>
               <a:spcAft>
-                <a:spcPts val="1500"/>
+                <a:spcPts val="1000"/>
               </a:spcAft>
             </a:pPr>
             <a:r>
-              <a:rPr sz="1800" b="1">
+              <a:rPr sz="2000" b="1">
                 <a:solidFill>
                   <a:srgbClr val="0E7490"/>
                 </a:solidFill>
                 <a:latin typeface="Arial"/>
               </a:rPr>
-              <a:t>🛡️ Browser AI CV</a:t>
+              <a:t>Proactive Driver Safety Co-Pilot:</a:t>
+            </a:r>
+          </a:p>
+          <a:p>
+            <a:pPr>
+              <a:spcAft>
+                <a:spcPts val="2000"/>
+              </a:spcAft>
+            </a:pPr>
+            <a:r>
+              <a:rPr sz="1500">
+                <a:solidFill>
+                  <a:srgbClr val="334155"/>
+                </a:solidFill>
+                <a:latin typeface="Arial"/>
+              </a:rPr>
+              <a:t>GuardianAI bridges the critical gap between video capturing and physical accident prevention. By using lightweight edge computer vision in the browser and asynchronous multi-agent models in the backend, it acts as a proactive safety co-pilot.</a:t>
             </a:r>
           </a:p>
           <a:p>
             <a:pPr>
               <a:spcBef>
-                <a:spcPts val="1000"/>
+                <a:spcPts val="800"/>
               </a:spcBef>
             </a:pPr>
             <a:r>
-              <a:rPr sz="1300">
+              <a:rPr sz="1500" b="1">
+                <a:solidFill>
+                  <a:srgbClr val="0E7490"/>
+                </a:solidFill>
+                <a:latin typeface="Arial"/>
+              </a:rPr>
+              <a:t>•  Attentiveness Indexing: </a:t>
+            </a:r>
+            <a:r>
+              <a:rPr sz="1400">
                 <a:solidFill>
                   <a:srgbClr val="334155"/>
                 </a:solidFill>
                 <a:latin typeface="Arial"/>
               </a:rPr>
-              <a:t>MediaPipe Holistic tracks 3D face mesh targets, arm segments, and 21-joint finger skeletons in the browser.</a:t>
-            </a:r>
-          </a:p>
-        </p:txBody>
-      </p:sp>
-      <p:sp>
-        <p:nvSpPr>
-          <p:cNvPr id="6" name="Rectangle 5"/>
-          <p:cNvSpPr/>
-          <p:nvPr/>
-        </p:nvSpPr>
-        <p:spPr>
-          <a:xfrm>
-            <a:off x="3337560" y="1645920"/>
-            <a:ext cx="2651760" cy="4297680"/>
-          </a:xfrm>
-          <a:prstGeom prst="rect">
-            <a:avLst/>
-          </a:prstGeom>
-          <a:solidFill>
-            <a:srgbClr val="F1F5F9"/>
-          </a:solidFill>
-          <a:ln w="19050">
-            <a:solidFill>
-              <a:srgbClr val="E2E8F0"/>
-            </a:solidFill>
-          </a:ln>
-        </p:spPr>
-        <p:style>
-          <a:lnRef idx="1">
-            <a:schemeClr val="accent1"/>
-          </a:lnRef>
-          <a:fillRef idx="3">
-            <a:schemeClr val="accent1"/>
-          </a:fillRef>
-          <a:effectRef idx="2">
-            <a:schemeClr val="accent1"/>
-          </a:effectRef>
-          <a:fontRef idx="minor">
-            <a:schemeClr val="lt1"/>
-          </a:fontRef>
-        </p:style>
-        <p:txBody>
-          <a:bodyPr rtlCol="0" anchor="ctr"/>
-          <a:lstStyle/>
-          <a:p>
-            <a:pPr algn="ctr"/>
-          </a:p>
-        </p:txBody>
-      </p:sp>
-      <p:sp>
-        <p:nvSpPr>
-          <p:cNvPr id="7" name="TextBox 6"/>
-          <p:cNvSpPr txBox="1"/>
-          <p:nvPr/>
-        </p:nvSpPr>
-        <p:spPr>
-          <a:xfrm>
-            <a:off x="3474720" y="1828800"/>
-            <a:ext cx="2377440" cy="3931920"/>
-          </a:xfrm>
-          <a:prstGeom prst="rect">
-            <a:avLst/>
-          </a:prstGeom>
-          <a:noFill/>
-        </p:spPr>
-        <p:txBody>
-          <a:bodyPr wrap="square">
-            <a:spAutoFit/>
-          </a:bodyPr>
-          <a:lstStyle/>
-          <a:p>
-            <a:pPr>
-              <a:spcAft>
-                <a:spcPts val="1500"/>
-              </a:spcAft>
-            </a:pPr>
-            <a:r>
-              <a:rPr sz="1800" b="1">
-                <a:solidFill>
-                  <a:srgbClr val="0F172A"/>
-                </a:solidFill>
-                <a:latin typeface="Arial"/>
-              </a:rPr>
-              <a:t>🧠 Asynchronous Agents</a:t>
+              <a:t>Continuously scores driver focus from 0 to 100 based on blink frequency, head angles, and yaw deviation.</a:t>
             </a:r>
           </a:p>
           <a:p>
             <a:pPr>
               <a:spcBef>
-                <a:spcPts val="1000"/>
+                <a:spcPts val="800"/>
               </a:spcBef>
             </a:pPr>
             <a:r>
-              <a:rPr sz="1300">
+              <a:rPr sz="1500" b="1">
+                <a:solidFill>
+                  <a:srgbClr val="0E7490"/>
+                </a:solidFill>
+                <a:latin typeface="Arial"/>
+              </a:rPr>
+              <a:t>•  Asynchronous Telemetry: </a:t>
+            </a:r>
+            <a:r>
+              <a:rPr sz="1400">
                 <a:solidFill>
                   <a:srgbClr val="334155"/>
                 </a:solidFill>
                 <a:latin typeface="Arial"/>
               </a:rPr>
-              <a:t>FastAPI agents (Driver, Vehicle, Predictor, Intervention) process telemetry events on an async bus.</a:t>
-            </a:r>
-          </a:p>
-        </p:txBody>
-      </p:sp>
-      <p:sp>
-        <p:nvSpPr>
-          <p:cNvPr id="8" name="Rectangle 7"/>
-          <p:cNvSpPr/>
-          <p:nvPr/>
-        </p:nvSpPr>
-        <p:spPr>
-          <a:xfrm>
-            <a:off x="6126479" y="1645920"/>
-            <a:ext cx="2651760" cy="4297680"/>
-          </a:xfrm>
-          <a:prstGeom prst="rect">
-            <a:avLst/>
-          </a:prstGeom>
-          <a:solidFill>
-            <a:srgbClr val="F1F5F9"/>
-          </a:solidFill>
-          <a:ln w="19050">
-            <a:solidFill>
-              <a:srgbClr val="E2E8F0"/>
-            </a:solidFill>
-          </a:ln>
-        </p:spPr>
-        <p:style>
-          <a:lnRef idx="1">
-            <a:schemeClr val="accent1"/>
-          </a:lnRef>
-          <a:fillRef idx="3">
-            <a:schemeClr val="accent1"/>
-          </a:fillRef>
-          <a:effectRef idx="2">
-            <a:schemeClr val="accent1"/>
-          </a:effectRef>
-          <a:fontRef idx="minor">
-            <a:schemeClr val="lt1"/>
-          </a:fontRef>
-        </p:style>
-        <p:txBody>
-          <a:bodyPr rtlCol="0" anchor="ctr"/>
-          <a:lstStyle/>
-          <a:p>
-            <a:pPr algn="ctr"/>
-          </a:p>
-        </p:txBody>
-      </p:sp>
-      <p:sp>
-        <p:nvSpPr>
-          <p:cNvPr id="9" name="TextBox 8"/>
-          <p:cNvSpPr txBox="1"/>
-          <p:nvPr/>
-        </p:nvSpPr>
-        <p:spPr>
-          <a:xfrm>
-            <a:off x="6263639" y="1828800"/>
-            <a:ext cx="2377440" cy="3931920"/>
-          </a:xfrm>
-          <a:prstGeom prst="rect">
-            <a:avLst/>
-          </a:prstGeom>
-          <a:noFill/>
-        </p:spPr>
-        <p:txBody>
-          <a:bodyPr wrap="square">
-            <a:spAutoFit/>
-          </a:bodyPr>
-          <a:lstStyle/>
-          <a:p>
-            <a:pPr>
-              <a:spcAft>
-                <a:spcPts val="1500"/>
-              </a:spcAft>
-            </a:pPr>
-            <a:r>
-              <a:rPr sz="1800" b="1">
-                <a:solidFill>
-                  <a:srgbClr val="0E7490"/>
-                </a:solidFill>
-                <a:latin typeface="Arial"/>
-              </a:rPr>
-              <a:t>🔊 Synth Siren Alerts</a:t>
+              <a:t>Combines driver posture with live steering and braking loops to calculate stability.</a:t>
             </a:r>
           </a:p>
           <a:p>
             <a:pPr>
               <a:spcBef>
-                <a:spcPts val="1000"/>
+                <a:spcPts val="800"/>
               </a:spcBef>
             </a:pPr>
             <a:r>
-              <a:rPr sz="1300">
+              <a:rPr sz="1500" b="1">
+                <a:solidFill>
+                  <a:srgbClr val="0E7490"/>
+                </a:solidFill>
+                <a:latin typeface="Arial"/>
+              </a:rPr>
+              <a:t>•  Collision Forecasting: </a:t>
+            </a:r>
+            <a:r>
+              <a:rPr sz="1400">
                 <a:solidFill>
                   <a:srgbClr val="334155"/>
                 </a:solidFill>
                 <a:latin typeface="Arial"/>
               </a:rPr>
-              <a:t>Web Audio oscillators produce urgent sirens and warning chimes during safety violations.</a:t>
-            </a:r>
-          </a:p>
-        </p:txBody>
-      </p:sp>
-      <p:sp>
-        <p:nvSpPr>
-          <p:cNvPr id="10" name="Rectangle 9"/>
-          <p:cNvSpPr/>
-          <p:nvPr/>
-        </p:nvSpPr>
-        <p:spPr>
-          <a:xfrm>
-            <a:off x="8915399" y="1645920"/>
-            <a:ext cx="2651760" cy="4297680"/>
-          </a:xfrm>
-          <a:prstGeom prst="rect">
-            <a:avLst/>
-          </a:prstGeom>
-          <a:solidFill>
-            <a:srgbClr val="F1F5F9"/>
-          </a:solidFill>
-          <a:ln w="19050">
-            <a:solidFill>
-              <a:srgbClr val="E2E8F0"/>
-            </a:solidFill>
-          </a:ln>
-        </p:spPr>
-        <p:style>
-          <a:lnRef idx="1">
-            <a:schemeClr val="accent1"/>
-          </a:lnRef>
-          <a:fillRef idx="3">
-            <a:schemeClr val="accent1"/>
-          </a:fillRef>
-          <a:effectRef idx="2">
-            <a:schemeClr val="accent1"/>
-          </a:effectRef>
-          <a:fontRef idx="minor">
-            <a:schemeClr val="lt1"/>
-          </a:fontRef>
-        </p:style>
-        <p:txBody>
-          <a:bodyPr rtlCol="0" anchor="ctr"/>
-          <a:lstStyle/>
-          <a:p>
-            <a:pPr algn="ctr"/>
-          </a:p>
-        </p:txBody>
-      </p:sp>
-      <p:sp>
-        <p:nvSpPr>
-          <p:cNvPr id="11" name="TextBox 10"/>
-          <p:cNvSpPr txBox="1"/>
-          <p:nvPr/>
-        </p:nvSpPr>
-        <p:spPr>
-          <a:xfrm>
-            <a:off x="9052559" y="1828800"/>
-            <a:ext cx="2377440" cy="3931920"/>
-          </a:xfrm>
-          <a:prstGeom prst="rect">
-            <a:avLst/>
-          </a:prstGeom>
-          <a:noFill/>
-        </p:spPr>
-        <p:txBody>
-          <a:bodyPr wrap="square">
-            <a:spAutoFit/>
-          </a:bodyPr>
-          <a:lstStyle/>
-          <a:p>
-            <a:pPr>
-              <a:spcAft>
-                <a:spcPts val="1500"/>
-              </a:spcAft>
-            </a:pPr>
-            <a:r>
-              <a:rPr sz="1800" b="1">
-                <a:solidFill>
-                  <a:srgbClr val="0F172A"/>
-                </a:solidFill>
-                <a:latin typeface="Arial"/>
-              </a:rPr>
-              <a:t>🎛️ Interactive Controls</a:t>
-            </a:r>
-          </a:p>
-          <a:p>
-            <a:pPr>
-              <a:spcBef>
-                <a:spcPts val="1000"/>
-              </a:spcBef>
-            </a:pPr>
-            <a:r>
-              <a:rPr sz="1300">
-                <a:solidFill>
-                  <a:srgbClr val="334155"/>
-                </a:solidFill>
-                <a:latin typeface="Arial"/>
-              </a:rPr>
-              <a:t>Speed, steering, and lane sliders allow manual overrides to instantly test accident risks.</a:t>
+              <a:t>Projects trajectory risk 3-5 seconds before impact, giving drivers enough time to take corrective action.</a:t>
             </a:r>
           </a:p>
         </p:txBody>
@@ -4068,7 +4001,6 @@
           </a:bodyPr>
           <a:lstStyle/>
           <a:p>
-            <a:pPr algn="l"/>
             <a:r>
               <a:rPr sz="2800" b="1">
                 <a:solidFill>
@@ -4076,21 +4008,66 @@
                 </a:solidFill>
                 <a:latin typeface="Arial"/>
               </a:rPr>
-              <a:t>Why We Built It That Way: Design Rationale</a:t>
-            </a:r>
-          </a:p>
-        </p:txBody>
-      </p:sp>
-      <p:sp>
-        <p:nvSpPr>
-          <p:cNvPr id="4" name="TextBox 3"/>
+              <a:t>System Architecture: 4 Collaborating AI Agents</a:t>
+            </a:r>
+          </a:p>
+        </p:txBody>
+      </p:sp>
+      <p:sp>
+        <p:nvSpPr>
+          <p:cNvPr id="4" name="Rectangle 3"/>
+          <p:cNvSpPr/>
+          <p:nvPr/>
+        </p:nvSpPr>
+        <p:spPr>
+          <a:xfrm>
+            <a:off x="548640" y="1645920"/>
+            <a:ext cx="2651760" cy="4297680"/>
+          </a:xfrm>
+          <a:prstGeom prst="rect">
+            <a:avLst/>
+          </a:prstGeom>
+          <a:solidFill>
+            <a:srgbClr val="F1F5F9"/>
+          </a:solidFill>
+          <a:ln w="19050">
+            <a:solidFill>
+              <a:srgbClr val="E2E8F0"/>
+            </a:solidFill>
+          </a:ln>
+        </p:spPr>
+        <p:style>
+          <a:lnRef idx="1">
+            <a:schemeClr val="accent1"/>
+          </a:lnRef>
+          <a:fillRef idx="3">
+            <a:schemeClr val="accent1"/>
+          </a:fillRef>
+          <a:effectRef idx="2">
+            <a:schemeClr val="accent1"/>
+          </a:effectRef>
+          <a:fontRef idx="minor">
+            <a:schemeClr val="lt1"/>
+          </a:fontRef>
+        </p:style>
+        <p:txBody>
+          <a:bodyPr rtlCol="0" anchor="ctr"/>
+          <a:lstStyle/>
+          <a:p>
+            <a:pPr algn="ctr"/>
+          </a:p>
+        </p:txBody>
+      </p:sp>
+      <p:sp>
+        <p:nvSpPr>
+          <p:cNvPr id="5" name="TextBox 4"/>
           <p:cNvSpPr txBox="1"/>
           <p:nvPr/>
         </p:nvSpPr>
         <p:spPr>
           <a:xfrm>
-            <a:off x="731520" y="1463040"/>
-            <a:ext cx="10698480" cy="4572000"/>
+            <a:off x="685800" y="1828800"/>
+            <a:ext cx="2377440" cy="3931920"/>
           </a:xfrm>
           <a:prstGeom prst="rect">
             <a:avLst/>
@@ -4102,110 +4079,336 @@
             <a:spAutoFit/>
           </a:bodyPr>
           <a:lstStyle/>
-          <a:p/>
+          <a:p>
+            <a:pPr>
+              <a:spcAft>
+                <a:spcPts val="1500"/>
+              </a:spcAft>
+            </a:pPr>
+            <a:r>
+              <a:rPr sz="1800" b="1">
+                <a:solidFill>
+                  <a:srgbClr val="0E7490"/>
+                </a:solidFill>
+                <a:latin typeface="Arial"/>
+              </a:rPr>
+              <a:t>🛡️ Driver Agent</a:t>
+            </a:r>
+          </a:p>
           <a:p>
             <a:pPr>
               <a:spcBef>
-                <a:spcPts val="1200"/>
+                <a:spcPts val="1000"/>
               </a:spcBef>
             </a:pPr>
             <a:r>
-              <a:rPr sz="1600" b="1">
-                <a:solidFill>
-                  <a:srgbClr val="0E7490"/>
-                </a:solidFill>
-                <a:latin typeface="Arial"/>
-              </a:rPr>
-              <a:t>✔  Edge-CV + Cloud Fusion Model: </a:t>
+              <a:rPr sz="1300">
+                <a:solidFill>
+                  <a:srgbClr val="334155"/>
+                </a:solidFill>
+                <a:latin typeface="Arial"/>
+              </a:rPr>
+              <a:t>Monitors face yaw, pitch, blink rate (EAR), and smartphone phone call postures.</a:t>
+            </a:r>
+          </a:p>
+        </p:txBody>
+      </p:sp>
+      <p:sp>
+        <p:nvSpPr>
+          <p:cNvPr id="6" name="Rectangle 5"/>
+          <p:cNvSpPr/>
+          <p:nvPr/>
+        </p:nvSpPr>
+        <p:spPr>
+          <a:xfrm>
+            <a:off x="3337560" y="1645920"/>
+            <a:ext cx="2651760" cy="4297680"/>
+          </a:xfrm>
+          <a:prstGeom prst="rect">
+            <a:avLst/>
+          </a:prstGeom>
+          <a:solidFill>
+            <a:srgbClr val="F1F5F9"/>
+          </a:solidFill>
+          <a:ln w="19050">
+            <a:solidFill>
+              <a:srgbClr val="E2E8F0"/>
+            </a:solidFill>
+          </a:ln>
+        </p:spPr>
+        <p:style>
+          <a:lnRef idx="1">
+            <a:schemeClr val="accent1"/>
+          </a:lnRef>
+          <a:fillRef idx="3">
+            <a:schemeClr val="accent1"/>
+          </a:fillRef>
+          <a:effectRef idx="2">
+            <a:schemeClr val="accent1"/>
+          </a:effectRef>
+          <a:fontRef idx="minor">
+            <a:schemeClr val="lt1"/>
+          </a:fontRef>
+        </p:style>
+        <p:txBody>
+          <a:bodyPr rtlCol="0" anchor="ctr"/>
+          <a:lstStyle/>
+          <a:p>
+            <a:pPr algn="ctr"/>
+          </a:p>
+        </p:txBody>
+      </p:sp>
+      <p:sp>
+        <p:nvSpPr>
+          <p:cNvPr id="7" name="TextBox 6"/>
+          <p:cNvSpPr txBox="1"/>
+          <p:nvPr/>
+        </p:nvSpPr>
+        <p:spPr>
+          <a:xfrm>
+            <a:off x="3474720" y="1828800"/>
+            <a:ext cx="2377440" cy="3931920"/>
+          </a:xfrm>
+          <a:prstGeom prst="rect">
+            <a:avLst/>
+          </a:prstGeom>
+          <a:noFill/>
+        </p:spPr>
+        <p:txBody>
+          <a:bodyPr wrap="square">
+            <a:spAutoFit/>
+          </a:bodyPr>
+          <a:lstStyle/>
+          <a:p>
+            <a:pPr>
+              <a:spcAft>
+                <a:spcPts val="1500"/>
+              </a:spcAft>
+            </a:pPr>
+            <a:r>
+              <a:rPr sz="1800" b="1">
+                <a:solidFill>
+                  <a:srgbClr val="0F172A"/>
+                </a:solidFill>
+                <a:latin typeface="Arial"/>
+              </a:rPr>
+              <a:t>🚗 Vehicle Agent</a:t>
             </a:r>
           </a:p>
           <a:p>
             <a:pPr>
               <a:spcBef>
-                <a:spcPts val="200"/>
+                <a:spcPts val="1000"/>
               </a:spcBef>
+            </a:pPr>
+            <a:r>
+              <a:rPr sz="1300">
+                <a:solidFill>
+                  <a:srgbClr val="334155"/>
+                </a:solidFill>
+                <a:latin typeface="Arial"/>
+              </a:rPr>
+              <a:t>Tracks speed, steering angle deviations, and road lane alignment values.</a:t>
+            </a:r>
+          </a:p>
+        </p:txBody>
+      </p:sp>
+      <p:sp>
+        <p:nvSpPr>
+          <p:cNvPr id="8" name="Rectangle 7"/>
+          <p:cNvSpPr/>
+          <p:nvPr/>
+        </p:nvSpPr>
+        <p:spPr>
+          <a:xfrm>
+            <a:off x="6126479" y="1645920"/>
+            <a:ext cx="2651760" cy="4297680"/>
+          </a:xfrm>
+          <a:prstGeom prst="rect">
+            <a:avLst/>
+          </a:prstGeom>
+          <a:solidFill>
+            <a:srgbClr val="F1F5F9"/>
+          </a:solidFill>
+          <a:ln w="19050">
+            <a:solidFill>
+              <a:srgbClr val="E2E8F0"/>
+            </a:solidFill>
+          </a:ln>
+        </p:spPr>
+        <p:style>
+          <a:lnRef idx="1">
+            <a:schemeClr val="accent1"/>
+          </a:lnRef>
+          <a:fillRef idx="3">
+            <a:schemeClr val="accent1"/>
+          </a:fillRef>
+          <a:effectRef idx="2">
+            <a:schemeClr val="accent1"/>
+          </a:effectRef>
+          <a:fontRef idx="minor">
+            <a:schemeClr val="lt1"/>
+          </a:fontRef>
+        </p:style>
+        <p:txBody>
+          <a:bodyPr rtlCol="0" anchor="ctr"/>
+          <a:lstStyle/>
+          <a:p>
+            <a:pPr algn="ctr"/>
+          </a:p>
+        </p:txBody>
+      </p:sp>
+      <p:sp>
+        <p:nvSpPr>
+          <p:cNvPr id="9" name="TextBox 8"/>
+          <p:cNvSpPr txBox="1"/>
+          <p:nvPr/>
+        </p:nvSpPr>
+        <p:spPr>
+          <a:xfrm>
+            <a:off x="6263639" y="1828800"/>
+            <a:ext cx="2377440" cy="3931920"/>
+          </a:xfrm>
+          <a:prstGeom prst="rect">
+            <a:avLst/>
+          </a:prstGeom>
+          <a:noFill/>
+        </p:spPr>
+        <p:txBody>
+          <a:bodyPr wrap="square">
+            <a:spAutoFit/>
+          </a:bodyPr>
+          <a:lstStyle/>
+          <a:p>
+            <a:pPr>
               <a:spcAft>
-                <a:spcPts val="800"/>
+                <a:spcPts val="1500"/>
               </a:spcAft>
             </a:pPr>
             <a:r>
-              <a:rPr sz="1400">
-                <a:solidFill>
-                  <a:srgbClr val="334155"/>
-                </a:solidFill>
-                <a:latin typeface="Arial"/>
-              </a:rPr>
-              <a:t>MediaPipe Holistic runs client-side in the browser. This eliminates expensive cloud GPU server hosting costs and guarantees zero latency overhead for frame capture processing (&lt;30ms).</a:t>
+              <a:rPr sz="1800" b="1">
+                <a:solidFill>
+                  <a:srgbClr val="0E7490"/>
+                </a:solidFill>
+                <a:latin typeface="Arial"/>
+              </a:rPr>
+              <a:t>🔮 Prediction Agent</a:t>
             </a:r>
           </a:p>
           <a:p>
             <a:pPr>
               <a:spcBef>
-                <a:spcPts val="1200"/>
+                <a:spcPts val="1000"/>
               </a:spcBef>
             </a:pPr>
             <a:r>
-              <a:rPr sz="1600" b="1">
-                <a:solidFill>
-                  <a:srgbClr val="0E7490"/>
-                </a:solidFill>
-                <a:latin typeface="Arial"/>
-              </a:rPr>
-              <a:t>✔  Asynchronous Event Bus Decoupling: </a:t>
+              <a:rPr sz="1300">
+                <a:solidFill>
+                  <a:srgbClr val="334155"/>
+                </a:solidFill>
+                <a:latin typeface="Arial"/>
+              </a:rPr>
+              <a:t>Fuses driver and vehicle features to forecast accident probability and type.</a:t>
+            </a:r>
+          </a:p>
+        </p:txBody>
+      </p:sp>
+      <p:sp>
+        <p:nvSpPr>
+          <p:cNvPr id="10" name="Rectangle 9"/>
+          <p:cNvSpPr/>
+          <p:nvPr/>
+        </p:nvSpPr>
+        <p:spPr>
+          <a:xfrm>
+            <a:off x="8915399" y="1645920"/>
+            <a:ext cx="2651760" cy="4297680"/>
+          </a:xfrm>
+          <a:prstGeom prst="rect">
+            <a:avLst/>
+          </a:prstGeom>
+          <a:solidFill>
+            <a:srgbClr val="F1F5F9"/>
+          </a:solidFill>
+          <a:ln w="19050">
+            <a:solidFill>
+              <a:srgbClr val="E2E8F0"/>
+            </a:solidFill>
+          </a:ln>
+        </p:spPr>
+        <p:style>
+          <a:lnRef idx="1">
+            <a:schemeClr val="accent1"/>
+          </a:lnRef>
+          <a:fillRef idx="3">
+            <a:schemeClr val="accent1"/>
+          </a:fillRef>
+          <a:effectRef idx="2">
+            <a:schemeClr val="accent1"/>
+          </a:effectRef>
+          <a:fontRef idx="minor">
+            <a:schemeClr val="lt1"/>
+          </a:fontRef>
+        </p:style>
+        <p:txBody>
+          <a:bodyPr rtlCol="0" anchor="ctr"/>
+          <a:lstStyle/>
+          <a:p>
+            <a:pPr algn="ctr"/>
+          </a:p>
+        </p:txBody>
+      </p:sp>
+      <p:sp>
+        <p:nvSpPr>
+          <p:cNvPr id="11" name="TextBox 10"/>
+          <p:cNvSpPr txBox="1"/>
+          <p:nvPr/>
+        </p:nvSpPr>
+        <p:spPr>
+          <a:xfrm>
+            <a:off x="9052559" y="1828800"/>
+            <a:ext cx="2377440" cy="3931920"/>
+          </a:xfrm>
+          <a:prstGeom prst="rect">
+            <a:avLst/>
+          </a:prstGeom>
+          <a:noFill/>
+        </p:spPr>
+        <p:txBody>
+          <a:bodyPr wrap="square">
+            <a:spAutoFit/>
+          </a:bodyPr>
+          <a:lstStyle/>
+          <a:p>
+            <a:pPr>
+              <a:spcAft>
+                <a:spcPts val="1500"/>
+              </a:spcAft>
+            </a:pPr>
+            <a:r>
+              <a:rPr sz="1800" b="1">
+                <a:solidFill>
+                  <a:srgbClr val="0F172A"/>
+                </a:solidFill>
+                <a:latin typeface="Arial"/>
+              </a:rPr>
+              <a:t>🚨 Intervention Agent</a:t>
             </a:r>
           </a:p>
           <a:p>
             <a:pPr>
               <a:spcBef>
-                <a:spcPts val="200"/>
-              </a:spcBef>
-              <a:spcAft>
-                <a:spcPts val="800"/>
-              </a:spcAft>
-            </a:pPr>
-            <a:r>
-              <a:rPr sz="1400">
-                <a:solidFill>
-                  <a:srgbClr val="334155"/>
-                </a:solidFill>
-                <a:latin typeface="Arial"/>
-              </a:rPr>
-              <a:t>Decouples telemetry loops (vehicle updates at 10Hz, camera landmarks at 30Hz). If the camera is toggled off, backend agents fallback to physics-simulations instantly.</a:t>
-            </a:r>
-          </a:p>
-          <a:p>
-            <a:pPr>
-              <a:spcBef>
-                <a:spcPts val="1200"/>
+                <a:spcPts val="1000"/>
               </a:spcBef>
             </a:pPr>
             <a:r>
-              <a:rPr sz="1600" b="1">
-                <a:solidFill>
-                  <a:srgbClr val="0E7490"/>
-                </a:solidFill>
-                <a:latin typeface="Arial"/>
-              </a:rPr>
-              <a:t>✔  Direct DOM Telemetry Updates: </a:t>
-            </a:r>
-          </a:p>
-          <a:p>
-            <a:pPr>
-              <a:spcBef>
-                <a:spcPts val="200"/>
-              </a:spcBef>
-              <a:spcAft>
-                <a:spcPts val="800"/>
-              </a:spcAft>
-            </a:pPr>
-            <a:r>
-              <a:rPr sz="1400">
+              <a:rPr sz="1300">
                 <a:solidFill>
                   <a:srgbClr val="334155"/>
                 </a:solidFill>
                 <a:latin typeface="Arial"/>
               </a:rPr>
-              <a:t>Rendering 30 FPS face mesh coords inside React state freezes the virtual DOM. We update HUD metrics directly in the DOM by ID, saving significant CPU cycles.</a:t>
+              <a:t>Escalates warnings (alarms, automatic deceleration instructions) to prevent crashes.</a:t>
             </a:r>
           </a:p>
         </p:txBody>
@@ -4301,7 +4504,6 @@
           </a:bodyPr>
           <a:lstStyle/>
           <a:p>
-            <a:pPr algn="l"/>
             <a:r>
               <a:rPr sz="2800" b="1">
                 <a:solidFill>
@@ -4309,7 +4511,7 @@
                 </a:solidFill>
                 <a:latin typeface="Arial"/>
               </a:rPr>
-              <a:t>How It Works: Technical Data Flow</a:t>
+              <a:t>Client-Side Edge AI: MediaPipe Holistic CV</a:t>
             </a:r>
           </a:p>
         </p:txBody>
@@ -4339,126 +4541,106 @@
           <a:p>
             <a:pPr>
               <a:spcBef>
-                <a:spcPts val="1000"/>
+                <a:spcPts val="1200"/>
               </a:spcBef>
             </a:pPr>
             <a:r>
-              <a:rPr sz="1500" b="1">
+              <a:rPr sz="1600" b="1">
                 <a:solidFill>
                   <a:srgbClr val="0E7490"/>
                 </a:solidFill>
                 <a:latin typeface="Arial"/>
               </a:rPr>
-              <a:t>•  1. Sensation: </a:t>
-            </a:r>
-            <a:r>
-              <a:rPr sz="1400">
-                <a:solidFill>
-                  <a:srgbClr val="334155"/>
-                </a:solidFill>
-                <a:latin typeface="Arial"/>
-              </a:rPr>
-              <a:t>Webcam captures raw frame video. MediaPipe tracks Eye Aspect Ratio (EAR), Mouth aspect (MAR), and Hand-to-Cheek distance vectors.</a:t>
+              <a:t>✔  Yaw &amp; Pitch angle estimation: </a:t>
             </a:r>
           </a:p>
           <a:p>
             <a:pPr>
               <a:spcBef>
-                <a:spcPts val="1000"/>
+                <a:spcPts val="200"/>
+              </a:spcBef>
+              <a:spcAft>
+                <a:spcPts val="800"/>
+              </a:spcAft>
+            </a:pPr>
+            <a:r>
+              <a:rPr sz="1400">
+                <a:solidFill>
+                  <a:srgbClr val="334155"/>
+                </a:solidFill>
+                <a:latin typeface="Arial"/>
+              </a:rPr>
+              <a:t>Uses scale-invariant nose-tip to eye ratios to catch left/right turns and up/down nodding.</a:t>
+            </a:r>
+          </a:p>
+          <a:p>
+            <a:pPr>
+              <a:spcBef>
+                <a:spcPts val="1200"/>
               </a:spcBef>
             </a:pPr>
             <a:r>
-              <a:rPr sz="1500" b="1">
+              <a:rPr sz="1600" b="1">
                 <a:solidFill>
                   <a:srgbClr val="0E7490"/>
                 </a:solidFill>
                 <a:latin typeface="Arial"/>
               </a:rPr>
-              <a:t>•  2. Transmission: </a:t>
-            </a:r>
-            <a:r>
-              <a:rPr sz="1400">
-                <a:solidFill>
-                  <a:srgbClr val="334155"/>
-                </a:solidFill>
-                <a:latin typeface="Arial"/>
-              </a:rPr>
-              <a:t>WebSockets stream coordinates to FastAPI's async event bus, throttled to 150ms to prevent server buffer overflows.</a:t>
+              <a:t>✔  Dual-Cheek proximity detection: </a:t>
             </a:r>
           </a:p>
           <a:p>
             <a:pPr>
               <a:spcBef>
-                <a:spcPts val="1000"/>
+                <a:spcPts val="200"/>
+              </a:spcBef>
+              <a:spcAft>
+                <a:spcPts val="800"/>
+              </a:spcAft>
+            </a:pPr>
+            <a:r>
+              <a:rPr sz="1400">
+                <a:solidFill>
+                  <a:srgbClr val="334155"/>
+                </a:solidFill>
+                <a:latin typeface="Arial"/>
+              </a:rPr>
+              <a:t>Checks wrist and finger landmarks to detect phone usage at either ear.</a:t>
+            </a:r>
+          </a:p>
+          <a:p>
+            <a:pPr>
+              <a:spcBef>
+                <a:spcPts val="1200"/>
               </a:spcBef>
             </a:pPr>
             <a:r>
-              <a:rPr sz="1500" b="1">
+              <a:rPr sz="1600" b="1">
                 <a:solidFill>
                   <a:srgbClr val="0E7490"/>
                 </a:solidFill>
                 <a:latin typeface="Arial"/>
               </a:rPr>
-              <a:t>•  3. Sequence Modeling: </a:t>
-            </a:r>
-            <a:r>
-              <a:rPr sz="1400">
-                <a:solidFill>
-                  <a:srgbClr val="334155"/>
-                </a:solidFill>
-                <a:latin typeface="Arial"/>
-              </a:rPr>
-              <a:t>Vehicle telemetry sequence (50, 10) passes through a BiGRU network; driver parameters are fused through a Transformer cross-attention encoder.</a:t>
+              <a:t>✔  Zero Server GPU Cost: </a:t>
             </a:r>
           </a:p>
           <a:p>
             <a:pPr>
               <a:spcBef>
-                <a:spcPts val="1000"/>
+                <a:spcPts val="200"/>
               </a:spcBef>
+              <a:spcAft>
+                <a:spcPts val="800"/>
+              </a:spcAft>
             </a:pPr>
             <a:r>
-              <a:rPr sz="1500" b="1">
-                <a:solidFill>
-                  <a:srgbClr val="0E7490"/>
-                </a:solidFill>
-                <a:latin typeface="Arial"/>
-              </a:rPr>
-              <a:t>•  4. Forecast: </a:t>
-            </a:r>
-            <a:r>
               <a:rPr sz="1400">
                 <a:solidFill>
                   <a:srgbClr val="334155"/>
                 </a:solidFill>
                 <a:latin typeface="Arial"/>
               </a:rPr>
-              <a:t>LSTM forecaster outputs collision probability and type (e.g. rear-end) 3-5 seconds ahead.</a:t>
-            </a:r>
-          </a:p>
-          <a:p>
-            <a:pPr>
-              <a:spcBef>
-                <a:spcPts val="1000"/>
-              </a:spcBef>
-            </a:pPr>
-            <a:r>
-              <a:rPr sz="1500" b="1">
-                <a:solidFill>
-                  <a:srgbClr val="0E7490"/>
-                </a:solidFill>
-                <a:latin typeface="Arial"/>
-              </a:rPr>
-              <a:t>•  5. Actuation: </a:t>
-            </a:r>
-            <a:r>
-              <a:rPr sz="1400">
-                <a:solidFill>
-                  <a:srgbClr val="334155"/>
-                </a:solidFill>
-                <a:latin typeface="Arial"/>
-              </a:rPr>
-              <a:t>Intervention Agent triggers wailing sirens in the browser and logs safety event audits into SQLite WAL database.</a:t>
+              <a:t>Processing frames locally reduces backend workload and solves bandwidth constraints.</a:t>
             </a:r>
           </a:p>
         </p:txBody>
@@ -4554,7 +4736,6 @@
           </a:bodyPr>
           <a:lstStyle/>
           <a:p>
-            <a:pPr algn="l"/>
             <a:r>
               <a:rPr sz="2800" b="1">
                 <a:solidFill>
@@ -4562,7 +4743,7 @@
                 </a:solidFill>
                 <a:latin typeface="Arial"/>
               </a:rPr>
-              <a:t>Trained Models &amp; System Verification</a:t>
+              <a:t>Backend Intelligence: PyTorch Neural Networks</a:t>
             </a:r>
           </a:p>
         </p:txBody>
@@ -4704,23 +4885,620 @@
               <a:t>accident_predictor.pt</a:t>
             </a:r>
           </a:p>
+        </p:txBody>
+      </p:sp>
+    </p:spTree>
+  </p:cSld>
+  <p:clrMapOvr>
+    <a:masterClrMapping/>
+  </p:clrMapOvr>
+</p:sld>
+</file>
+
+<file path=ppt/slides/slide7.xml><?xml version="1.0" encoding="utf-8"?>
+<p:sld xmlns:a="http://schemas.openxmlformats.org/drawingml/2006/main" xmlns:p="http://schemas.openxmlformats.org/presentationml/2006/main" xmlns:r="http://schemas.openxmlformats.org/officeDocument/2006/relationships">
+  <p:cSld>
+    <p:bg>
+      <p:bgPr>
+        <a:solidFill>
+          <a:srgbClr val="FFFFFF"/>
+        </a:solidFill>
+        <a:effectLst/>
+      </p:bgPr>
+    </p:bg>
+    <p:spTree>
+      <p:nvGrpSpPr>
+        <p:cNvPr id="1" name=""/>
+        <p:cNvGrpSpPr/>
+        <p:nvPr/>
+      </p:nvGrpSpPr>
+      <p:grpSpPr/>
+      <p:sp>
+        <p:nvSpPr>
+          <p:cNvPr id="2" name="Rectangle 1"/>
+          <p:cNvSpPr/>
+          <p:nvPr/>
+        </p:nvSpPr>
+        <p:spPr>
+          <a:xfrm>
+            <a:off x="0" y="0"/>
+            <a:ext cx="12191695" cy="1005840"/>
+          </a:xfrm>
+          <a:prstGeom prst="rect">
+            <a:avLst/>
+          </a:prstGeom>
+          <a:solidFill>
+            <a:srgbClr val="0F172A"/>
+          </a:solidFill>
+          <a:ln>
+            <a:noFill/>
+          </a:ln>
+        </p:spPr>
+        <p:style>
+          <a:lnRef idx="1">
+            <a:schemeClr val="accent1"/>
+          </a:lnRef>
+          <a:fillRef idx="3">
+            <a:schemeClr val="accent1"/>
+          </a:fillRef>
+          <a:effectRef idx="2">
+            <a:schemeClr val="accent1"/>
+          </a:effectRef>
+          <a:fontRef idx="minor">
+            <a:schemeClr val="lt1"/>
+          </a:fontRef>
+        </p:style>
+        <p:txBody>
+          <a:bodyPr rtlCol="0" anchor="ctr"/>
+          <a:lstStyle/>
+          <a:p>
+            <a:pPr algn="ctr"/>
+          </a:p>
+        </p:txBody>
+      </p:sp>
+      <p:sp>
+        <p:nvSpPr>
+          <p:cNvPr id="3" name="TextBox 2"/>
+          <p:cNvSpPr txBox="1"/>
+          <p:nvPr/>
+        </p:nvSpPr>
+        <p:spPr>
+          <a:xfrm>
+            <a:off x="548640" y="182880"/>
+            <a:ext cx="11094415" cy="640080"/>
+          </a:xfrm>
+          <a:prstGeom prst="rect">
+            <a:avLst/>
+          </a:prstGeom>
+          <a:noFill/>
+        </p:spPr>
+        <p:txBody>
+          <a:bodyPr wrap="square">
+            <a:spAutoFit/>
+          </a:bodyPr>
+          <a:lstStyle/>
+          <a:p>
+            <a:r>
+              <a:rPr sz="2800" b="1">
+                <a:solidFill>
+                  <a:srgbClr val="FFFFFF"/>
+                </a:solidFill>
+                <a:latin typeface="Arial"/>
+              </a:rPr>
+              <a:t>Intervention Agent Escalation Ladder</a:t>
+            </a:r>
+          </a:p>
+        </p:txBody>
+      </p:sp>
+      <p:sp>
+        <p:nvSpPr>
+          <p:cNvPr id="4" name="TextBox 3"/>
+          <p:cNvSpPr txBox="1"/>
+          <p:nvPr/>
+        </p:nvSpPr>
+        <p:spPr>
+          <a:xfrm>
+            <a:off x="731520" y="1463040"/>
+            <a:ext cx="10698480" cy="4572000"/>
+          </a:xfrm>
+          <a:prstGeom prst="rect">
+            <a:avLst/>
+          </a:prstGeom>
+          <a:noFill/>
+        </p:spPr>
+        <p:txBody>
+          <a:bodyPr wrap="square">
+            <a:spAutoFit/>
+          </a:bodyPr>
+          <a:lstStyle/>
+          <a:p>
+            <a:pPr>
+              <a:spcAft>
+                <a:spcPts val="800"/>
+              </a:spcAft>
+            </a:pPr>
+            <a:r>
+              <a:rPr sz="1600" b="1">
+                <a:solidFill>
+                  <a:srgbClr val="0F172A"/>
+                </a:solidFill>
+                <a:latin typeface="Arial"/>
+              </a:rPr>
+              <a:t>Mapping Risk Scores to System Interventions:</a:t>
+            </a:r>
+          </a:p>
           <a:p>
             <a:pPr>
               <a:spcBef>
-                <a:spcPts val="1800"/>
+                <a:spcPts val="800"/>
+              </a:spcBef>
+            </a:pPr>
+            <a:r>
+              <a:rPr sz="1500" b="1">
+                <a:solidFill>
+                  <a:srgbClr val="0E7490"/>
+                </a:solidFill>
+                <a:latin typeface="Arial"/>
+              </a:rPr>
+              <a:t>•  0 - 25% (LOW): </a:t>
+            </a:r>
+            <a:r>
+              <a:rPr sz="1400">
+                <a:solidFill>
+                  <a:srgbClr val="334155"/>
+                </a:solidFill>
+                <a:latin typeface="Arial"/>
+              </a:rPr>
+              <a:t>Normal operations, background monitoring active.</a:t>
+            </a:r>
+          </a:p>
+          <a:p>
+            <a:pPr>
+              <a:spcBef>
+                <a:spcPts val="800"/>
+              </a:spcBef>
+            </a:pPr>
+            <a:r>
+              <a:rPr sz="1500" b="1">
+                <a:solidFill>
+                  <a:srgbClr val="0E7490"/>
+                </a:solidFill>
+                <a:latin typeface="Arial"/>
+              </a:rPr>
+              <a:t>•  25 - 50% (MEDIUM): </a:t>
+            </a:r>
+            <a:r>
+              <a:rPr sz="1400">
+                <a:solidFill>
+                  <a:srgbClr val="334155"/>
+                </a:solidFill>
+                <a:latin typeface="Arial"/>
+              </a:rPr>
+              <a:t>Caution advisory tips played on screen, voice guidance starts.</a:t>
+            </a:r>
+          </a:p>
+          <a:p>
+            <a:pPr>
+              <a:spcBef>
+                <a:spcPts val="800"/>
+              </a:spcBef>
+            </a:pPr>
+            <a:r>
+              <a:rPr sz="1500" b="1">
+                <a:solidFill>
+                  <a:srgbClr val="0E7490"/>
+                </a:solidFill>
+                <a:latin typeface="Arial"/>
+              </a:rPr>
+              <a:t>•  50 - 75% (HIGH): </a:t>
+            </a:r>
+            <a:r>
+              <a:rPr sz="1400">
+                <a:solidFill>
+                  <a:srgbClr val="334155"/>
+                </a:solidFill>
+                <a:latin typeface="Arial"/>
+              </a:rPr>
+              <a:t>Warning wailing sirens sound, lane alignment advisory active.</a:t>
+            </a:r>
+          </a:p>
+          <a:p>
+            <a:pPr>
+              <a:spcBef>
+                <a:spcPts val="800"/>
+              </a:spcBef>
+            </a:pPr>
+            <a:r>
+              <a:rPr sz="1500" b="1">
+                <a:solidFill>
+                  <a:srgbClr val="0E7490"/>
+                </a:solidFill>
+                <a:latin typeface="Arial"/>
+              </a:rPr>
+              <a:t>•  75 - 100% (CRITICAL): </a:t>
+            </a:r>
+            <a:r>
+              <a:rPr sz="1400">
+                <a:solidFill>
+                  <a:srgbClr val="334155"/>
+                </a:solidFill>
+                <a:latin typeface="Arial"/>
+              </a:rPr>
+              <a:t>High-pitched siren sounded, automatic deceleration instruction sent.</a:t>
+            </a:r>
+          </a:p>
+        </p:txBody>
+      </p:sp>
+    </p:spTree>
+  </p:cSld>
+  <p:clrMapOvr>
+    <a:masterClrMapping/>
+  </p:clrMapOvr>
+</p:sld>
+</file>
+
+<file path=ppt/slides/slide8.xml><?xml version="1.0" encoding="utf-8"?>
+<p:sld xmlns:a="http://schemas.openxmlformats.org/drawingml/2006/main" xmlns:p="http://schemas.openxmlformats.org/presentationml/2006/main" xmlns:r="http://schemas.openxmlformats.org/officeDocument/2006/relationships">
+  <p:cSld>
+    <p:bg>
+      <p:bgPr>
+        <a:solidFill>
+          <a:srgbClr val="FFFFFF"/>
+        </a:solidFill>
+        <a:effectLst/>
+      </p:bgPr>
+    </p:bg>
+    <p:spTree>
+      <p:nvGrpSpPr>
+        <p:cNvPr id="1" name=""/>
+        <p:cNvGrpSpPr/>
+        <p:nvPr/>
+      </p:nvGrpSpPr>
+      <p:grpSpPr/>
+      <p:sp>
+        <p:nvSpPr>
+          <p:cNvPr id="2" name="Rectangle 1"/>
+          <p:cNvSpPr/>
+          <p:nvPr/>
+        </p:nvSpPr>
+        <p:spPr>
+          <a:xfrm>
+            <a:off x="0" y="0"/>
+            <a:ext cx="12191695" cy="1005840"/>
+          </a:xfrm>
+          <a:prstGeom prst="rect">
+            <a:avLst/>
+          </a:prstGeom>
+          <a:solidFill>
+            <a:srgbClr val="0F172A"/>
+          </a:solidFill>
+          <a:ln>
+            <a:noFill/>
+          </a:ln>
+        </p:spPr>
+        <p:style>
+          <a:lnRef idx="1">
+            <a:schemeClr val="accent1"/>
+          </a:lnRef>
+          <a:fillRef idx="3">
+            <a:schemeClr val="accent1"/>
+          </a:fillRef>
+          <a:effectRef idx="2">
+            <a:schemeClr val="accent1"/>
+          </a:effectRef>
+          <a:fontRef idx="minor">
+            <a:schemeClr val="lt1"/>
+          </a:fontRef>
+        </p:style>
+        <p:txBody>
+          <a:bodyPr rtlCol="0" anchor="ctr"/>
+          <a:lstStyle/>
+          <a:p>
+            <a:pPr algn="ctr"/>
+          </a:p>
+        </p:txBody>
+      </p:sp>
+      <p:sp>
+        <p:nvSpPr>
+          <p:cNvPr id="3" name="TextBox 2"/>
+          <p:cNvSpPr txBox="1"/>
+          <p:nvPr/>
+        </p:nvSpPr>
+        <p:spPr>
+          <a:xfrm>
+            <a:off x="548640" y="182880"/>
+            <a:ext cx="11094415" cy="640080"/>
+          </a:xfrm>
+          <a:prstGeom prst="rect">
+            <a:avLst/>
+          </a:prstGeom>
+          <a:noFill/>
+        </p:spPr>
+        <p:txBody>
+          <a:bodyPr wrap="square">
+            <a:spAutoFit/>
+          </a:bodyPr>
+          <a:lstStyle/>
+          <a:p>
+            <a:r>
+              <a:rPr sz="2800" b="1">
+                <a:solidFill>
+                  <a:srgbClr val="FFFFFF"/>
+                </a:solidFill>
+                <a:latin typeface="Arial"/>
+              </a:rPr>
+              <a:t>Interactive Cockpit Sliders &amp; DOM Optimization</a:t>
+            </a:r>
+          </a:p>
+        </p:txBody>
+      </p:sp>
+      <p:sp>
+        <p:nvSpPr>
+          <p:cNvPr id="4" name="TextBox 3"/>
+          <p:cNvSpPr txBox="1"/>
+          <p:nvPr/>
+        </p:nvSpPr>
+        <p:spPr>
+          <a:xfrm>
+            <a:off x="731520" y="1463040"/>
+            <a:ext cx="10698480" cy="4572000"/>
+          </a:xfrm>
+          <a:prstGeom prst="rect">
+            <a:avLst/>
+          </a:prstGeom>
+          <a:noFill/>
+        </p:spPr>
+        <p:txBody>
+          <a:bodyPr wrap="square">
+            <a:spAutoFit/>
+          </a:bodyPr>
+          <a:lstStyle/>
+          <a:p/>
+          <a:p>
+            <a:pPr>
+              <a:spcBef>
+                <a:spcPts val="1200"/>
+              </a:spcBef>
+            </a:pPr>
+            <a:r>
+              <a:rPr sz="1600" b="1">
+                <a:solidFill>
+                  <a:srgbClr val="0E7490"/>
+                </a:solidFill>
+                <a:latin typeface="Arial"/>
+              </a:rPr>
+              <a:t>✔  Telemetry Override sliders: </a:t>
+            </a:r>
+          </a:p>
+          <a:p>
+            <a:pPr>
+              <a:spcBef>
+                <a:spcPts val="200"/>
               </a:spcBef>
               <a:spcAft>
-                <a:spcPts val="600"/>
+                <a:spcPts val="800"/>
               </a:spcAft>
             </a:pPr>
             <a:r>
+              <a:rPr sz="1400">
+                <a:solidFill>
+                  <a:srgbClr val="334155"/>
+                </a:solidFill>
+                <a:latin typeface="Arial"/>
+              </a:rPr>
+              <a:t>Control speed, steering angle, and lane alignment variables directly in the dashboard UI to simulate emergency risk conditions.</a:t>
+            </a:r>
+          </a:p>
+          <a:p>
+            <a:pPr>
+              <a:spcBef>
+                <a:spcPts val="1200"/>
+              </a:spcBef>
+            </a:pPr>
+            <a:r>
               <a:rPr sz="1600" b="1">
                 <a:solidFill>
+                  <a:srgbClr val="0E7490"/>
+                </a:solidFill>
+                <a:latin typeface="Arial"/>
+              </a:rPr>
+              <a:t>✔  Direct DOM Node Updates: </a:t>
+            </a:r>
+          </a:p>
+          <a:p>
+            <a:pPr>
+              <a:spcBef>
+                <a:spcPts val="200"/>
+              </a:spcBef>
+              <a:spcAft>
+                <a:spcPts val="800"/>
+              </a:spcAft>
+            </a:pPr>
+            <a:r>
+              <a:rPr sz="1400">
+                <a:solidFill>
+                  <a:srgbClr val="334155"/>
+                </a:solidFill>
+                <a:latin typeface="Arial"/>
+              </a:rPr>
+              <a:t>Excludes high-frequency eye and landmark values from the React state cycle. Coordinates are updated directly via element IDs, preventing interface lag.</a:t>
+            </a:r>
+          </a:p>
+          <a:p>
+            <a:pPr>
+              <a:spcBef>
+                <a:spcPts val="1200"/>
+              </a:spcBef>
+            </a:pPr>
+            <a:r>
+              <a:rPr sz="1600" b="1">
+                <a:solidFill>
+                  <a:srgbClr val="0E7490"/>
+                </a:solidFill>
+                <a:latin typeface="Arial"/>
+              </a:rPr>
+              <a:t>✔  Throttled Sockets: </a:t>
+            </a:r>
+          </a:p>
+          <a:p>
+            <a:pPr>
+              <a:spcBef>
+                <a:spcPts val="200"/>
+              </a:spcBef>
+              <a:spcAft>
+                <a:spcPts val="800"/>
+              </a:spcAft>
+            </a:pPr>
+            <a:r>
+              <a:rPr sz="1400">
+                <a:solidFill>
+                  <a:srgbClr val="334155"/>
+                </a:solidFill>
+                <a:latin typeface="Arial"/>
+              </a:rPr>
+              <a:t>Transfers webcam parameters to the backend at 150ms intervals, avoiding websocket buffers overloading.</a:t>
+            </a:r>
+          </a:p>
+        </p:txBody>
+      </p:sp>
+    </p:spTree>
+  </p:cSld>
+  <p:clrMapOvr>
+    <a:masterClrMapping/>
+  </p:clrMapOvr>
+</p:sld>
+</file>
+
+<file path=ppt/slides/slide9.xml><?xml version="1.0" encoding="utf-8"?>
+<p:sld xmlns:a="http://schemas.openxmlformats.org/drawingml/2006/main" xmlns:p="http://schemas.openxmlformats.org/presentationml/2006/main" xmlns:r="http://schemas.openxmlformats.org/officeDocument/2006/relationships">
+  <p:cSld>
+    <p:bg>
+      <p:bgPr>
+        <a:solidFill>
+          <a:srgbClr val="FFFFFF"/>
+        </a:solidFill>
+        <a:effectLst/>
+      </p:bgPr>
+    </p:bg>
+    <p:spTree>
+      <p:nvGrpSpPr>
+        <p:cNvPr id="1" name=""/>
+        <p:cNvGrpSpPr/>
+        <p:nvPr/>
+      </p:nvGrpSpPr>
+      <p:grpSpPr/>
+      <p:sp>
+        <p:nvSpPr>
+          <p:cNvPr id="2" name="Rectangle 1"/>
+          <p:cNvSpPr/>
+          <p:nvPr/>
+        </p:nvSpPr>
+        <p:spPr>
+          <a:xfrm>
+            <a:off x="0" y="0"/>
+            <a:ext cx="12191695" cy="1005840"/>
+          </a:xfrm>
+          <a:prstGeom prst="rect">
+            <a:avLst/>
+          </a:prstGeom>
+          <a:solidFill>
+            <a:srgbClr val="0F172A"/>
+          </a:solidFill>
+          <a:ln>
+            <a:noFill/>
+          </a:ln>
+        </p:spPr>
+        <p:style>
+          <a:lnRef idx="1">
+            <a:schemeClr val="accent1"/>
+          </a:lnRef>
+          <a:fillRef idx="3">
+            <a:schemeClr val="accent1"/>
+          </a:fillRef>
+          <a:effectRef idx="2">
+            <a:schemeClr val="accent1"/>
+          </a:effectRef>
+          <a:fontRef idx="minor">
+            <a:schemeClr val="lt1"/>
+          </a:fontRef>
+        </p:style>
+        <p:txBody>
+          <a:bodyPr rtlCol="0" anchor="ctr"/>
+          <a:lstStyle/>
+          <a:p>
+            <a:pPr algn="ctr"/>
+          </a:p>
+        </p:txBody>
+      </p:sp>
+      <p:sp>
+        <p:nvSpPr>
+          <p:cNvPr id="3" name="TextBox 2"/>
+          <p:cNvSpPr txBox="1"/>
+          <p:nvPr/>
+        </p:nvSpPr>
+        <p:spPr>
+          <a:xfrm>
+            <a:off x="548640" y="182880"/>
+            <a:ext cx="11094415" cy="640080"/>
+          </a:xfrm>
+          <a:prstGeom prst="rect">
+            <a:avLst/>
+          </a:prstGeom>
+          <a:noFill/>
+        </p:spPr>
+        <p:txBody>
+          <a:bodyPr wrap="square">
+            <a:spAutoFit/>
+          </a:bodyPr>
+          <a:lstStyle/>
+          <a:p>
+            <a:r>
+              <a:rPr sz="2800" b="1">
+                <a:solidFill>
+                  <a:srgbClr val="FFFFFF"/>
+                </a:solidFill>
+                <a:latin typeface="Arial"/>
+              </a:rPr>
+              <a:t>System Verification &amp; Test Metrics</a:t>
+            </a:r>
+          </a:p>
+        </p:txBody>
+      </p:sp>
+      <p:sp>
+        <p:nvSpPr>
+          <p:cNvPr id="4" name="TextBox 3"/>
+          <p:cNvSpPr txBox="1"/>
+          <p:nvPr/>
+        </p:nvSpPr>
+        <p:spPr>
+          <a:xfrm>
+            <a:off x="731520" y="1463040"/>
+            <a:ext cx="10698480" cy="4572000"/>
+          </a:xfrm>
+          <a:prstGeom prst="rect">
+            <a:avLst/>
+          </a:prstGeom>
+          <a:noFill/>
+        </p:spPr>
+        <p:txBody>
+          <a:bodyPr wrap="square">
+            <a:spAutoFit/>
+          </a:bodyPr>
+          <a:lstStyle/>
+          <a:p>
+            <a:pPr>
+              <a:spcAft>
+                <a:spcPts val="1000"/>
+              </a:spcAft>
+            </a:pPr>
+            <a:r>
+              <a:rPr sz="1800" b="1">
+                <a:solidFill>
                   <a:srgbClr val="0F172A"/>
                 </a:solidFill>
                 <a:latin typeface="Arial"/>
               </a:rPr>
-              <a:t>2. System Verification Metrics:</a:t>
+              <a:t>System Verification Metrics:</a:t>
             </a:r>
           </a:p>
           <a:p>
@@ -4760,6 +5538,31 @@
                 <a:latin typeface="Arial"/>
               </a:rPr>
               <a:t>Inference is completed under 10ms via PyTorch cpu optimization layers, exceeding the 100ms budget.</a:t>
+            </a:r>
+          </a:p>
+          <a:p>
+            <a:pPr>
+              <a:spcBef>
+                <a:spcPts val="1500"/>
+              </a:spcBef>
+            </a:pPr>
+            <a:r>
+              <a:rPr sz="1400" b="1">
+                <a:solidFill>
+                  <a:srgbClr val="0E7490"/>
+                </a:solidFill>
+                <a:latin typeface="Arial"/>
+              </a:rPr>
+              <a:t>✔  Robust Fallback: </a:t>
+            </a:r>
+            <a:r>
+              <a:rPr sz="1400">
+                <a:solidFill>
+                  <a:srgbClr val="334155"/>
+                </a:solidFill>
+                <a:latin typeface="Arial"/>
+              </a:rPr>
+              <a:t>If PyTorch model checkpoints are missing, the agents fallback automatically to rule-based simulations to prevent system crashes.</a:t>
             </a:r>
           </a:p>
         </p:txBody>

</xml_diff>

<commit_message>
Fix slide decks by removing all emojis for 100% standard PPTX/PDF reader compatibility
</commit_message>
<xml_diff>
--- a/guardian_ai_presentation.pptx
+++ b/guardian_ai_presentation.pptx
@@ -3177,7 +3177,7 @@
                 </a:solidFill>
                 <a:latin typeface="Arial"/>
               </a:rPr>
-              <a:t>GUARDIAN-AI 🛡️</a:t>
+              <a:t>GUARDIAN-AI</a:t>
             </a:r>
           </a:p>
           <a:p>
@@ -3380,7 +3380,7 @@
                 </a:solidFill>
                 <a:latin typeface="Arial"/>
               </a:rPr>
-              <a:t>•  Mass Adoption: </a:t>
+              <a:t>- Mass Adoption: </a:t>
             </a:r>
             <a:r>
               <a:rPr sz="1400">
@@ -3405,7 +3405,7 @@
                 </a:solidFill>
                 <a:latin typeface="Arial"/>
               </a:rPr>
-              <a:t>•  Cloud Deployments: </a:t>
+              <a:t>- Cloud Deployments: </a:t>
             </a:r>
             <a:r>
               <a:rPr sz="1400">
@@ -3430,7 +3430,7 @@
                 </a:solidFill>
                 <a:latin typeface="Arial"/>
               </a:rPr>
-              <a:t>•  Future V2X Integration: </a:t>
+              <a:t>- Future V2X Integration: </a:t>
             </a:r>
             <a:r>
               <a:rPr sz="1400">
@@ -3613,7 +3613,7 @@
                 </a:solidFill>
                 <a:latin typeface="Arial"/>
               </a:rPr>
-              <a:t>•  Driver Fatigue &amp; Micro-sleeps: </a:t>
+              <a:t>- Driver Fatigue &amp; Micro-sleeps: </a:t>
             </a:r>
             <a:r>
               <a:rPr sz="1400">
@@ -3638,7 +3638,7 @@
                 </a:solidFill>
                 <a:latin typeface="Arial"/>
               </a:rPr>
-              <a:t>•  Visual Distractions (Smartphone Usage): </a:t>
+              <a:t>- Visual Distractions (Smartphone Usage): </a:t>
             </a:r>
             <a:r>
               <a:rPr sz="1400">
@@ -3663,7 +3663,7 @@
                 </a:solidFill>
                 <a:latin typeface="Arial"/>
               </a:rPr>
-              <a:t>•  Passive Dashcam Monitoring: </a:t>
+              <a:t>- Passive Dashcam Monitoring: </a:t>
             </a:r>
             <a:r>
               <a:rPr sz="1400">
@@ -3846,7 +3846,7 @@
                 </a:solidFill>
                 <a:latin typeface="Arial"/>
               </a:rPr>
-              <a:t>•  Attentiveness Indexing: </a:t>
+              <a:t>- Attentiveness Indexing: </a:t>
             </a:r>
             <a:r>
               <a:rPr sz="1400">
@@ -3871,7 +3871,7 @@
                 </a:solidFill>
                 <a:latin typeface="Arial"/>
               </a:rPr>
-              <a:t>•  Asynchronous Telemetry: </a:t>
+              <a:t>- Asynchronous Telemetry: </a:t>
             </a:r>
             <a:r>
               <a:rPr sz="1400">
@@ -3896,7 +3896,7 @@
                 </a:solidFill>
                 <a:latin typeface="Arial"/>
               </a:rPr>
-              <a:t>•  Collision Forecasting: </a:t>
+              <a:t>- Collision Forecasting: </a:t>
             </a:r>
             <a:r>
               <a:rPr sz="1400">
@@ -4092,7 +4092,7 @@
                 </a:solidFill>
                 <a:latin typeface="Arial"/>
               </a:rPr>
-              <a:t>🛡️ Driver Agent</a:t>
+              <a:t>[Driver Agent]</a:t>
             </a:r>
           </a:p>
           <a:p>
@@ -4192,7 +4192,7 @@
                 </a:solidFill>
                 <a:latin typeface="Arial"/>
               </a:rPr>
-              <a:t>🚗 Vehicle Agent</a:t>
+              <a:t>[Vehicle Agent]</a:t>
             </a:r>
           </a:p>
           <a:p>
@@ -4292,7 +4292,7 @@
                 </a:solidFill>
                 <a:latin typeface="Arial"/>
               </a:rPr>
-              <a:t>🔮 Prediction Agent</a:t>
+              <a:t>[Prediction Agent]</a:t>
             </a:r>
           </a:p>
           <a:p>
@@ -4392,7 +4392,7 @@
                 </a:solidFill>
                 <a:latin typeface="Arial"/>
               </a:rPr>
-              <a:t>🚨 Intervention Agent</a:t>
+              <a:t>[Intervention Agent]</a:t>
             </a:r>
           </a:p>
           <a:p>
@@ -4551,7 +4551,7 @@
                 </a:solidFill>
                 <a:latin typeface="Arial"/>
               </a:rPr>
-              <a:t>✔  Yaw &amp; Pitch angle estimation: </a:t>
+              <a:t>[PASS]  Yaw &amp; Pitch angle estimation: </a:t>
             </a:r>
           </a:p>
           <a:p>
@@ -4586,7 +4586,7 @@
                 </a:solidFill>
                 <a:latin typeface="Arial"/>
               </a:rPr>
-              <a:t>✔  Dual-Cheek proximity detection: </a:t>
+              <a:t>[PASS]  Dual-Cheek proximity detection: </a:t>
             </a:r>
           </a:p>
           <a:p>
@@ -4621,7 +4621,7 @@
                 </a:solidFill>
                 <a:latin typeface="Arial"/>
               </a:rPr>
-              <a:t>✔  Zero Server GPU Cost: </a:t>
+              <a:t>[PASS]  Zero Server GPU Cost: </a:t>
             </a:r>
           </a:p>
           <a:p>
@@ -5040,7 +5040,7 @@
                 </a:solidFill>
                 <a:latin typeface="Arial"/>
               </a:rPr>
-              <a:t>•  0 - 25% (LOW): </a:t>
+              <a:t>- 0 - 25% (LOW): </a:t>
             </a:r>
             <a:r>
               <a:rPr sz="1400">
@@ -5065,7 +5065,7 @@
                 </a:solidFill>
                 <a:latin typeface="Arial"/>
               </a:rPr>
-              <a:t>•  25 - 50% (MEDIUM): </a:t>
+              <a:t>- 25 - 50% (MEDIUM): </a:t>
             </a:r>
             <a:r>
               <a:rPr sz="1400">
@@ -5090,7 +5090,7 @@
                 </a:solidFill>
                 <a:latin typeface="Arial"/>
               </a:rPr>
-              <a:t>•  50 - 75% (HIGH): </a:t>
+              <a:t>- 50 - 75% (HIGH): </a:t>
             </a:r>
             <a:r>
               <a:rPr sz="1400">
@@ -5115,7 +5115,7 @@
                 </a:solidFill>
                 <a:latin typeface="Arial"/>
               </a:rPr>
-              <a:t>•  75 - 100% (CRITICAL): </a:t>
+              <a:t>- 75 - 100% (CRITICAL): </a:t>
             </a:r>
             <a:r>
               <a:rPr sz="1400">
@@ -5267,7 +5267,7 @@
                 </a:solidFill>
                 <a:latin typeface="Arial"/>
               </a:rPr>
-              <a:t>✔  Telemetry Override sliders: </a:t>
+              <a:t>[PASS]  Telemetry Override sliders: </a:t>
             </a:r>
           </a:p>
           <a:p>
@@ -5302,7 +5302,7 @@
                 </a:solidFill>
                 <a:latin typeface="Arial"/>
               </a:rPr>
-              <a:t>✔  Direct DOM Node Updates: </a:t>
+              <a:t>[PASS]  Direct DOM Node Updates: </a:t>
             </a:r>
           </a:p>
           <a:p>
@@ -5337,7 +5337,7 @@
                 </a:solidFill>
                 <a:latin typeface="Arial"/>
               </a:rPr>
-              <a:t>✔  Throttled Sockets: </a:t>
+              <a:t>[PASS]  Throttled Sockets: </a:t>
             </a:r>
           </a:p>
           <a:p>
@@ -5509,7 +5509,7 @@
                 </a:solidFill>
                 <a:latin typeface="Arial"/>
               </a:rPr>
-              <a:t>✔  Pytest Suite: </a:t>
+              <a:t>[PASS]  Pytest Suite: </a:t>
             </a:r>
             <a:r>
               <a:rPr sz="1400">
@@ -5528,7 +5528,7 @@
                 </a:solidFill>
                 <a:latin typeface="Arial"/>
               </a:rPr>
-              <a:t>✔  Inference Latency: </a:t>
+              <a:t>[PASS]  Inference Latency: </a:t>
             </a:r>
             <a:r>
               <a:rPr sz="1400">
@@ -5553,7 +5553,7 @@
                 </a:solidFill>
                 <a:latin typeface="Arial"/>
               </a:rPr>
-              <a:t>✔  Robust Fallback: </a:t>
+              <a:t>[PASS]  Robust Fallback: </a:t>
             </a:r>
             <a:r>
               <a:rPr sz="1400">

</xml_diff>